<commit_message>
Updated the integrated M3E canvas window, debugger orchestrator, memory governor, and documentation suite
</commit_message>
<xml_diff>
--- a/website/public/campaign/INVESTOR-PITCH-DECK.pptx
+++ b/website/public/campaign/INVESTOR-PITCH-DECK.pptx
@@ -522,11 +522,11 @@
 Tone: Visionary, market-aware, confident, and relentlessly focused on the technical moat
 Core Thesis: AI coding is experiencing a massive architectural paradigm shift from centralized, cloud-locked, rate-limited SaaS tools to sovereign, local-first, multi-harness autonomous IDEs. Ty-Code owns this transition.
 [Visual Description]
-Deep Obsidian Cyber canvas (#0b0d10) illuminated by a pulsating emerald-green Decode-Frontier horizon line. Crisp, modern typography centered on screen with the Ty-Code cryptographic shield icon and glowing status indicator. Sub-text in high-contrast cyan: "Seed Financing Round — Q4 2026".
+Deep Obsidian Cyber canvas (#0b0d10) illuminated by a pulsating emerald-green Decode-Frontier horizon line. Crisp, modern typography centered on screen with the Ty-Code cryptographic shield icon and glowing status indicator. Sub-text in high-contrast cyan: "Seed Financing Round, Q4 2026".
 [Speaker Notes (Verbatim Script)]
-"Good morning, everyone. Over the last two years, we've watched generative AI fundamentally transform how software gets written. But the first generation of AI coding tools—tools like Cursor, GitHub Copilot, and Windsurf—were built on an architectural premise that is already breaking down.
+"Good morning, everyone. Over the last two years, we've watched generative AI fundamentally transform how software gets written. But the first generation of AI coding tools, tools like Cursor, GitHub Copilot, and Windsurf, were built on an architectural premise that is already breaking down.
 That premise was simple: send all the developer's source code, ASTs, and terminal sessions up to a centralized cloud, run inference behind a walled garden, and charge a $20-a-month seat tax.
-Today, we're introducing Ty-Code. Ty-Code is the world's first true local-first, zero-telemetry agentic AI desktop IDE. We didn't build another thin API wrapper. We re-architected the entire development environment from the metal up so that your code, your context, and your credentials never leave your machine—while unlocking over 1.3 billion free monthly tokens across 11 autonomous runtime harnesses.
+Today, we're introducing Ty-Code. Ty-Code is the world's first true local-first, zero-telemetry agentic AI desktop IDE. We didn't build another thin API wrapper. We re-architected the entire development environment from the metal up so that your code, your context, and your credentials never leave your machine, while unlocking over 1.3 billion free monthly tokens across 11 autonomous runtime harnesses.
 We're here today to show you how Ty-Code is transforming AI coding from an expensive security liability into an enterprise-grade sovereign superpower."</a:t>
             </a:r>
             <a:endParaRPr lang="en-US" dirty="0"/>
@@ -1091,7 +1091,7 @@
 - 20% Security Audits &amp; Community Growth (Third-party penetration testing, open-source hackathons)
 [Speaker Notes (Verbatim Script)]
 "To accelerate our growth and capitalize on this massive market window, we are raising a $3.5 million Seed round.
-We will deploy 50% of this capital directly into our core systems engineering team—expanding our multi-agent orchestration capabilities and deepening our local model optimizations. 30% will fund enterprise sales and compliance certifications, including SOC2 Type II audits and automated MDM connectors. The remaining 20% will support third-party security audits and global developer community initiatives.
+We will deploy 50% of this capital directly into our core systems engineering team, expanding our multi-agent orchestration capabilities and deepening our local model optimizations. 30% will fund enterprise sales and compliance certifications, including SOC2 Type II audits and automated MDM connectors. The remaining 20% will support third-party security audits and global developer community initiatives.
 Over the next 18 months, this capital will take us to 250,000 active developers, over 50 regulated enterprise deployments, and $4.2 million in high-margin Annual Recurring Revenue.
 The future of artificial intelligence in software engineering cannot belong to closed, cloud-locked monopolies that treat your source code as their training data. The future is local, private, resilient, and sovereign.
 We're building that future today with Ty-Code, and we invite you to join us. Thank you, and I look forward to your questions."</a:t>
@@ -1189,7 +1189,7 @@
 3. The Outage Wall: An editor locked in an HTTP 429 error dialog during an upstream cloud outage (tagged: "Vendor Lock-in").
 [Speaker Notes (Verbatim Script)]
 "Let's be direct about the problem with today's market leaders. Every time a developer presses Tab in Cursor or Copilot, their proprietary IP is packaged into an AST payload and transmitted across the open web to a third-party server.
-For solo hobbyists building toy apps, that might feel acceptable. But for the Fortune 500—for banks, hospitals, defense contractors, and security-conscious tech startups—that is an absolute non-starter. CISOs across the globe are issuing outright bans on cloud AI IDEs because they cannot risk HIPAA violations, SOC2 breaches, or source code leaks.
+For solo hobbyists building toy apps, that might feel acceptable. But for the Fortune 500, for banks, hospitals, defense contractors, and security-conscious tech startups, that is an absolute non-starter. CISOs across the globe are issuing outright bans on cloud AI IDEs because they cannot risk HIPAA violations, SOC2 breaches, or source code leaks.
 On top of the security nightmare, developers are getting squeezed by what we call the '$20-a-month seat tax.' Users are paying monthly subscriptions for tools that artificially throttle them the minute they hit a complex refactor, while marking up underlying API costs by 300%.
 And when the provider's centralized servers go down, development at the entire company stops dead. The industry is begging for compute sovereignty."</a:t>
             </a:r>
@@ -1284,7 +1284,7 @@
 [Speaker Notes (Verbatim Script)]
 "Ty-Code completely inverts this paradigm. We believe that your intellectual property belongs exclusively to you.
 In Ty-Code, all indexing, file tree parsing, and agentic workflows happen entirely within the local process space. We don't have telemetry servers. We don't store your prompts. In fact, Ty-Code is architecturally incapable of exfiltrating your code.
-When an engineer enters their API keys, those keys aren't saved in plaintext or dumped into browser cookies. They are cryptographically sealed inside the operating system's native hardware vault using safeStorage—DPAPI on Windows, Keychain on Mac, Secret Service on Linux.
+When an engineer enters their API keys, those keys aren't saved in plaintext or dumped into browser cookies. They are cryptographically sealed inside the operating system's native hardware vault using safeStorage, DPAPI on Windows, Keychain on Mac, Secret Service on Linux.
 Developers can bring their own keys at wholesale provider rates, connect private VPC gateways, or unplug their internet connection entirely and run state-of-the-art models like DeepSeek and Llama 3 locally via Ollama.
 It is uncompromising security paired with unrestricted developer freedom."</a:t>
             </a:r>
@@ -1381,9 +1381,9 @@
 - SOM: $1.1B Initial Target: 3.5M security-focused developers, startups, and regulated engineering teams.
 [Speaker Notes (Verbatim Script)]
 "The market tailwinds behind this shift are staggering. Over 30 million software engineers are actively integrating AI into their daily workflows, driving the developer tooling market toward $28.5 billion over the next three years.
-But here is the critical market insight that our competitors are missing: the highest-value segment of this market—the enterprise tier with the largest budgets—is currently locked out.
+But here is the critical market insight that our competitors are missing: the highest-value segment of this market, the enterprise tier with the largest budgets, is currently locked out.
 When a hospital network with 2,000 engineers wants to give their developers AI coding tools, they can't sign an enterprise Cursor contract without violating HIPAA. When a defense contractor wants autonomous agentic refactoring, they can't upload classified avionics code to a multitenant cloud.
-By solving data sovereignty and compliance at the architectural root, Ty-Code doesn't just compete for individual devs on Twitter—we unlock the massive, unserved enterprise market that has been forced to sit on the sidelines."</a:t>
+By solving data sovereignty and compliance at the architectural root, Ty-Code doesn't just compete for individual devs on Twitter, we unlock the massive, unserved enterprise market that has been forced to sit on the sidelines."</a:t>
             </a:r>
             <a:endParaRPr lang="en-US" dirty="0"/>
           </a:p>
@@ -1478,10 +1478,10 @@
 - Right Panel: M3E Visual UI Canvas synchronized bidirectionally with React code.
 - Bottom Panel: Sandboxed terminal executing verified PTY commands with active secret scrubbing.
 [Speaker Notes (Verbatim Script)]
-"When developers open Ty-Code, there is zero friction and zero cognitive overhead. It's built on Monaco—the exact same editor core powering VS Code—so every keybinding, theme, language server, and extension works intuitively on Day 1.
+"When developers open Ty-Code, there is zero friction and zero cognitive overhead. It's built on Monaco, the exact same editor core powering VS Code, so every keybinding, theme, language server, and extension works intuitively on Day 1.
 Notice what's happening on screen right now. We engineered a proprietary Decode-Frontier engine for LLM streaming. Instead of sluggish UI layout re-renders or choppy markdown jumps, code arrives via a deterministic 140-character-per-second decode sweep that keeps the UI silky smooth at 60 frames per second.
 To the right, you see our M3E Canvas. Developers can visually tweak components, inspect design tokens, and watch production-ready Tailwind and React code update live in the editor.
-And when the AI executes terminal commands—running tests, building bundles, installing dependencies—it does so inside our isolated three-tier PTY sandbox that scrubs environment variables and blocks dangerous commands before they ever execute."</a:t>
+And when the AI executes terminal commands, running tests, building bundles, installing dependencies, it does so inside our isolated three-tier PTY sandbox that scrubs environment variables and blocks dangerous commands before they ever execute."</a:t>
             </a:r>
             <a:endParaRPr lang="en-US" dirty="0"/>
           </a:p>
@@ -1576,7 +1576,7 @@
 "Now let's talk about our technical moat, because this is where Ty-Code leaves traditional wrappers in the dust.
 If you've used standard AI tools, you know the frustration of having your agent crash halfway through a complex refactor because Anthropic hit an HTTP 429 rate limit or an API had a temporary hiccup.
 We solved this with our Omni-Orchestrator and Unified ProviderGateway. We normalized over 60 different AI providers into one unified, ultra-low-latency reactive stream.
-Our orchestrator continuously pings providers, tracks latency, and forecasts token burn rates. If an upstream model experiences packet loss or throttling, Ty-Code automatically fails over to an equivalent high-speed provider—like Groq or OpenRouter—in under 50 milliseconds, preserving the entire conversational state and agentic tool-call history.
+Our orchestrator continuously pings providers, tracks latency, and forecasts token burn rates. If an upstream model experiences packet loss or throttling, Ty-Code automatically fails over to an equivalent high-speed provider, like Groq or OpenRouter, in under 50 milliseconds, preserving the entire conversational state and agentic tool-call history.
 The developer never sees a crash. They just see blistering-fast, uninterrupted code generation."</a:t>
             </a:r>
             <a:endParaRPr lang="en-US" dirty="0"/>
@@ -1667,7 +1667,7 @@
               <a:rPr lang="en-US" dirty="0"/>
               <a:t>[Speaker Notes]
 "This diagram illustrates our proprietary failover chain in action. When a query is initiated, the Unified ProviderGateway evaluates active latency and quota telemetry across all available endpoints.
-If a primary endpoint reports elevated latency or begins throwing HTTP 429 warnings, the 48ms Zero-Drop Failover Bus instantly migrates the streaming turn to an available secondary provider—such as Groq or local Ollama—without losing conversational turn tokens, tool invocation payloads, or editor focus."</a:t>
+If a primary endpoint reports elevated latency or begins throwing HTTP 429 warnings, the 48ms Zero-Drop Failover Bus instantly migrates the streaming turn to an available secondary provider, such as Groq or local Ollama, without losing conversational turn tokens, tool invocation payloads, or editor focus."</a:t>
             </a:r>
             <a:endParaRPr lang="en-US" dirty="0"/>
           </a:p>
@@ -1763,7 +1763,7 @@
 4. Codebase Scanner ("Structural AST Index")
 [Speaker Notes (Verbatim Script)]
 "Here is our second major moat: memory and context.
-Every developer has had the experience of correcting an AI model—telling it, 'Don't use var, use const,' or 'Always use our internal Result monad for error handling'—only for the model to make the exact same mistake ten minutes later in a new chat.
+Every developer has had the experience of correcting an AI model, telling it, 'Don't use var, use const,' or 'Always use our internal Result monad for error handling', only for the model to make the exact same mistake ten minutes later in a new chat.
 Ty-Code features a persistent Universal Correction Memory powered by a zero-overhead local SQLite database with write-ahead logging.
 The moment you correct Ty-Code in the chat, that rule is codified and indexed across your entire workspace. The next time you open the Omni-Debugger, it automatically flags code violating that rule. When the AI generates UI on the M3E Canvas, it automatically enforces your learned design tokens.
 This creates a compounding data flywheel on the user's local machine. The longer you use Ty-Code, the more tailored it becomes to your architecture. Switching away from Ty-Code means downgrading to an AI that doesn't know how your team builds software."</a:t>
@@ -1858,7 +1858,7 @@
 A centerpiece architecture diagram showcasing Ty-Code's multi-harness loopback engine:
 A central dispatch router connects to 11 distinct runtime harnesses (Claude Code, Codex, VS Code Extension APIs, Pi, OpenCode, Cline, Aider, Hermes, DeepSeek, Grok, Mistral). A local loopback supply adapter connects into the free-claude-code (FCC) reverse proxy layer, unlocking a visible badge: "1.3B+ Free Tokens / Month".
 [Speaker Notes (Verbatim Script)]
-"This brings us to our secret weapon—our growth engine that makes Ty-Code virtually impossible for competitors to displace.
+"This brings us to our secret weapon, our growth engine that makes Ty-Code virtually impossible for competitors to displace.
 One of the hardest hurdles in developer tooling is the onboarding friction of API keys and credit cards. If a developer has to pull out their corporate credit card or configure billing just to test your IDE, you lose 80% of your funnel.
 We completely eliminated that friction by building an open-source multi-harness router that unlocks over 1.3 billion free monthly tokens across 11 different runtime harnesses, including Claude Code, Codex, VS Code APIs, and Cline.
 A developer can download Ty-Code right now and immediately begin generating code with world-class models without paying a dime or entering a single credential. That gives us an unbeatable wedge against paid competitors charging $20 a month."</a:t>

</xml_diff>